<commit_message>
Clarify First Five grade bands
</commit_message>
<xml_diff>
--- a/resources/procedures/staff-learning/culture-systems-staff-learning-slides.pptx
+++ b/resources/procedures/staff-learning/culture-systems-staff-learning-slides.pptx
@@ -2,34 +2,34 @@
 <file path=ppt/presentation.xml><?xml version="1.0" encoding="utf-8"?>
 <p:presentation xmlns:p="http://schemas.openxmlformats.org/presentationml/2006/main">
   <p:sldMasterIdLst>
-    <p:sldMasterId xmlns:r="http://schemas.openxmlformats.org/officeDocument/2006/relationships" id="2147483648" r:id="Ra3121d0ad1844e5a"/>
+    <p:sldMasterId xmlns:r="http://schemas.openxmlformats.org/officeDocument/2006/relationships" id="2147483648" r:id="R2bfe1c52793c407c"/>
   </p:sldMasterIdLst>
   <p:notesMasterIdLst>
-    <p:notesMasterId xmlns:r="http://schemas.openxmlformats.org/officeDocument/2006/relationships" r:id="Ra0de21b16c65439b"/>
+    <p:notesMasterId xmlns:r="http://schemas.openxmlformats.org/officeDocument/2006/relationships" r:id="Rea228fb8a20149ce"/>
   </p:notesMasterIdLst>
   <p:sldIdLst>
-    <p:sldId xmlns:r="http://schemas.openxmlformats.org/officeDocument/2006/relationships" id="256" r:id="Raf1ad37baaad4be4"/>
-    <p:sldId xmlns:r="http://schemas.openxmlformats.org/officeDocument/2006/relationships" id="257" r:id="R39ded8813b08486c"/>
-    <p:sldId xmlns:r="http://schemas.openxmlformats.org/officeDocument/2006/relationships" id="258" r:id="R7afb9e4d2e024801"/>
-    <p:sldId xmlns:r="http://schemas.openxmlformats.org/officeDocument/2006/relationships" id="259" r:id="R52d7f1a02cce4962"/>
-    <p:sldId xmlns:r="http://schemas.openxmlformats.org/officeDocument/2006/relationships" id="260" r:id="R0ceff351ac1b4959"/>
-    <p:sldId xmlns:r="http://schemas.openxmlformats.org/officeDocument/2006/relationships" id="261" r:id="R6db0b3562d024ea1"/>
-    <p:sldId xmlns:r="http://schemas.openxmlformats.org/officeDocument/2006/relationships" id="262" r:id="Ra78045dedac845dc"/>
-    <p:sldId xmlns:r="http://schemas.openxmlformats.org/officeDocument/2006/relationships" id="263" r:id="Re2c5623281bc4a01"/>
-    <p:sldId xmlns:r="http://schemas.openxmlformats.org/officeDocument/2006/relationships" id="264" r:id="Rd3107eca98a04ab5"/>
-    <p:sldId xmlns:r="http://schemas.openxmlformats.org/officeDocument/2006/relationships" id="265" r:id="R0f998e20a76643bb"/>
-    <p:sldId xmlns:r="http://schemas.openxmlformats.org/officeDocument/2006/relationships" id="266" r:id="R03a32b54f7914cf3"/>
-    <p:sldId xmlns:r="http://schemas.openxmlformats.org/officeDocument/2006/relationships" id="267" r:id="R7678fe4f9f674562"/>
-    <p:sldId xmlns:r="http://schemas.openxmlformats.org/officeDocument/2006/relationships" id="268" r:id="R2670fe3f873047f5"/>
-    <p:sldId xmlns:r="http://schemas.openxmlformats.org/officeDocument/2006/relationships" id="269" r:id="Rae7af11d8e914c4e"/>
-    <p:sldId xmlns:r="http://schemas.openxmlformats.org/officeDocument/2006/relationships" id="270" r:id="Rbd533789ae934f32"/>
-    <p:sldId xmlns:r="http://schemas.openxmlformats.org/officeDocument/2006/relationships" id="271" r:id="Rb18ab872df4343bf"/>
-    <p:sldId xmlns:r="http://schemas.openxmlformats.org/officeDocument/2006/relationships" id="272" r:id="R28cd6a4ea63845cd"/>
-    <p:sldId xmlns:r="http://schemas.openxmlformats.org/officeDocument/2006/relationships" id="273" r:id="R984e8851ca7a40d8"/>
-    <p:sldId xmlns:r="http://schemas.openxmlformats.org/officeDocument/2006/relationships" id="274" r:id="R7ad9a0719ec0440a"/>
-    <p:sldId xmlns:r="http://schemas.openxmlformats.org/officeDocument/2006/relationships" id="275" r:id="R0b5e737dc7e748ce"/>
-    <p:sldId xmlns:r="http://schemas.openxmlformats.org/officeDocument/2006/relationships" id="276" r:id="Rda9eb08a7ad044c4"/>
-    <p:sldId xmlns:r="http://schemas.openxmlformats.org/officeDocument/2006/relationships" id="277" r:id="R18457a013ad54ee0"/>
+    <p:sldId xmlns:r="http://schemas.openxmlformats.org/officeDocument/2006/relationships" id="256" r:id="R9f93866261704a7a"/>
+    <p:sldId xmlns:r="http://schemas.openxmlformats.org/officeDocument/2006/relationships" id="257" r:id="Red40f1fc3c6d4a66"/>
+    <p:sldId xmlns:r="http://schemas.openxmlformats.org/officeDocument/2006/relationships" id="258" r:id="R3c1f52dd6bad4b21"/>
+    <p:sldId xmlns:r="http://schemas.openxmlformats.org/officeDocument/2006/relationships" id="259" r:id="R7e44b22ece8c4cc9"/>
+    <p:sldId xmlns:r="http://schemas.openxmlformats.org/officeDocument/2006/relationships" id="260" r:id="R48117e2a808f4045"/>
+    <p:sldId xmlns:r="http://schemas.openxmlformats.org/officeDocument/2006/relationships" id="261" r:id="Rc1b3d418f23b4da5"/>
+    <p:sldId xmlns:r="http://schemas.openxmlformats.org/officeDocument/2006/relationships" id="262" r:id="R2fa2cef8f7504177"/>
+    <p:sldId xmlns:r="http://schemas.openxmlformats.org/officeDocument/2006/relationships" id="263" r:id="Rc1f12ef4979a45e2"/>
+    <p:sldId xmlns:r="http://schemas.openxmlformats.org/officeDocument/2006/relationships" id="264" r:id="R0adf0d6212ac455f"/>
+    <p:sldId xmlns:r="http://schemas.openxmlformats.org/officeDocument/2006/relationships" id="265" r:id="Rb8e060a8bdbd49be"/>
+    <p:sldId xmlns:r="http://schemas.openxmlformats.org/officeDocument/2006/relationships" id="266" r:id="R5d518f46eef04130"/>
+    <p:sldId xmlns:r="http://schemas.openxmlformats.org/officeDocument/2006/relationships" id="267" r:id="Rd36da75689ef40f7"/>
+    <p:sldId xmlns:r="http://schemas.openxmlformats.org/officeDocument/2006/relationships" id="268" r:id="Rcdd1cfee21eb45fe"/>
+    <p:sldId xmlns:r="http://schemas.openxmlformats.org/officeDocument/2006/relationships" id="269" r:id="R2e55952b38b3429d"/>
+    <p:sldId xmlns:r="http://schemas.openxmlformats.org/officeDocument/2006/relationships" id="270" r:id="Rd1131e3a827545f1"/>
+    <p:sldId xmlns:r="http://schemas.openxmlformats.org/officeDocument/2006/relationships" id="271" r:id="R2a828852b1e944ce"/>
+    <p:sldId xmlns:r="http://schemas.openxmlformats.org/officeDocument/2006/relationships" id="272" r:id="R057e33e52683459b"/>
+    <p:sldId xmlns:r="http://schemas.openxmlformats.org/officeDocument/2006/relationships" id="273" r:id="Rf719212f0017415a"/>
+    <p:sldId xmlns:r="http://schemas.openxmlformats.org/officeDocument/2006/relationships" id="274" r:id="Rf81fa9f2b3994ec7"/>
+    <p:sldId xmlns:r="http://schemas.openxmlformats.org/officeDocument/2006/relationships" id="275" r:id="Rb46e26c62b6d4fb2"/>
+    <p:sldId xmlns:r="http://schemas.openxmlformats.org/officeDocument/2006/relationships" id="276" r:id="R01a5ec8df3114d6e"/>
+    <p:sldId xmlns:r="http://schemas.openxmlformats.org/officeDocument/2006/relationships" id="277" r:id="Ra61e1c6076d248e3"/>
   </p:sldIdLst>
   <p:sldSz cx="12192000" cy="6858000"/>
   <p:notesSz cx="6858000" cy="9144000"/>
@@ -2319,7 +2319,7 @@
   </p:cSld>
   <p:clrMap bg1="lt1" tx1="dk1" bg2="dk2" tx2="lt2" accent1="accent1" accent2="accent2" accent3="accent3" accent4="accent4" accent5="accent5" accent6="accent6" hlink="hlink" folHlink="folHlink"/>
   <p:sldLayoutIdLst>
-    <p:sldLayoutId xmlns:r="http://schemas.openxmlformats.org/officeDocument/2006/relationships" id="2147483649" r:id="Rbca5c3dc4d244259"/>
+    <p:sldLayoutId xmlns:r="http://schemas.openxmlformats.org/officeDocument/2006/relationships" id="2147483649" r:id="Rd29d14c18f4f43fa"/>
   </p:sldLayoutIdLst>
   <p:hf sldNum="0" hdr="0" ftr="0" dt="0"/>
   <p:txStyles>
@@ -4595,7 +4595,7 @@
                 <a:ea typeface="Calibri"/>
                 <a:cs typeface="Calibri"/>
               </a:rPr>
-              <a:t>Entering (First Five) &amp; Exiting — K–5: electives/other spaces · 6–8: class periods</a:t>
+              <a:t>Entering (First Five) &amp; Exiting — K–2 &amp; 3–5: electives/other spaces · 6–8: class periods</a:t>
             </a:r>
           </a:p>
           <a:p xmlns:a="http://schemas.openxmlformats.org/drawingml/2006/main">
@@ -8357,7 +8357,7 @@
                 <a:cs typeface="Calibri"/>
               </a:rPr>
               <a:t>Morning Circle Transition · Attention-Getter · Indoor Recess
-First Five is K–8: K–5 for electives/other spaces; 6–8 across class periods</a:t>
+First Five is K–8: K–2 &amp; 3–5 for electives/other spaces; 6–8 across class periods</a:t>
             </a:r>
           </a:p>
           <a:p xmlns:a="http://schemas.openxmlformats.org/drawingml/2006/main">

</xml_diff>